<commit_message>
docs: Dokumentation aktualisiert (Changelog, Funktionsreferenz, StateMachines, Bedienungsanleitung)
Bedienungsanleitung einheitlich auf bTn_Wecker_*-Namensschema umbenannt.

Co-Authored-By: Claude Opus 4.6 <noreply@anthropic.com>
</commit_message>
<xml_diff>
--- a/Dokumentation/Diagramme/bTn_Wecker_StateMachines.pptx
+++ b/Dokumentation/Diagramme/bTn_Wecker_StateMachines.pptx
@@ -1538,7 +1538,7 @@
                 <a:ea typeface="Arial" pitchFamily="34" charset="-122"/>
                 <a:cs typeface="Arial" pitchFamily="34" charset="-120"/>
               </a:rPr>
-              <a:t>sec==0  ·  min==aX_min  ·  hour==aX_hour  ·  min≠lastAXMin</a:t>
+              <a:t>sec==0 · min==aX_min · hour==aX_hour · min≠lastAXMin</a:t>
             </a:r>
             <a:endParaRPr lang="en-US" sz="800" dirty="0"/>
           </a:p>
@@ -1602,7 +1602,7 @@
                 <a:ea typeface="Arial" pitchFamily="34" charset="-122"/>
                 <a:cs typeface="Arial" pitchFamily="34" charset="-120"/>
               </a:rPr>
-              <a:t>playerStatus &lt; 1  (MP3 beendet)  ·  alle ALARM_POLL_MS (5 s)</a:t>
+              <a:t>playerStatus == 0  (MP3 beendet)  ·  alle ALARM_POLL_MS (5 s)</a:t>
             </a:r>
             <a:endParaRPr lang="en-US" sz="800" dirty="0"/>
           </a:p>
@@ -1795,12 +1795,10 @@
         <p:spPr>
           <a:xfrm>
             <a:off x="365760" y="5029200"/>
-            <a:ext cx="11430000" cy="1280160"/>
-          </a:xfrm>
-          <a:prstGeom prst="rect">
-            <a:avLst>
-              <a:gd name="adj" fmla="val 5714"/>
-            </a:avLst>
+            <a:ext cx="11430000" cy="1463040"/>
+          </a:xfrm>
+          <a:prstGeom prst="rect">
+            <a:avLst/>
           </a:prstGeom>
           <a:solidFill>
             <a:srgbClr val="FFFDE7"/>
@@ -1822,7 +1820,7 @@
         <p:spPr>
           <a:xfrm>
             <a:off x="548640" y="5120640"/>
-            <a:ext cx="11064240" cy="1097280"/>
+            <a:ext cx="11064240" cy="1280160"/>
           </a:xfrm>
           <a:prstGeom prst="rect">
             <a:avLst/>
@@ -1860,7 +1858,7 @@
                 <a:ea typeface="Arial" pitchFamily="34" charset="-122"/>
                 <a:cs typeface="Arial" pitchFamily="34" charset="-120"/>
               </a:rPr>
-              <a:t>aX_on=true · sec==0 · min==aX_min · hour==aX_hour · min≠lastAXMin (Minuten-Sperre)</a:t>
+              <a:t>aX_on=true · sec==0 · min==aX_min · hour==aX_hour · min≠lastAXMin · playFolder() unter playerMutex erfolgreich (9v14: kein stiller Alarm bei Mutex-Timeout)</a:t>
             </a:r>
             <a:pPr indent="0" marL="0">
               <a:buNone/>
@@ -1932,7 +1930,7 @@
                 <a:ea typeface="Arial" pitchFamily="34" charset="-122"/>
                 <a:cs typeface="Arial" pitchFamily="34" charset="-120"/>
               </a:rPr>
-              <a:t>playerMutex:  </a:t>
+              <a:t>playerStatus:  </a:t>
             </a:r>
             <a:pPr indent="0" marL="0">
               <a:buNone/>
@@ -1946,7 +1944,7 @@
                 <a:ea typeface="Arial" pitchFamily="34" charset="-122"/>
                 <a:cs typeface="Arial" pitchFamily="34" charset="-120"/>
               </a:rPr>
-              <a:t>schützt playFolder()- und readState()-Aufrufe. vTaskDelay(1ms) liegt außerhalb des Mutex.</a:t>
+              <a:t>== 0 (9v4: war &lt; 1) verhindert Fehlabbruch bei readState()-Timeout (UART-Konflikt mit webLogTask)</a:t>
             </a:r>
             <a:endParaRPr lang="en-US" sz="900" dirty="0"/>
           </a:p>
@@ -2597,7 +2595,7 @@
                 <a:ea typeface="Arial" pitchFamily="34" charset="-122"/>
                 <a:cs typeface="Arial" pitchFamily="34" charset="-120"/>
               </a:rPr>
-              <a:t>Zeitfenster-Prüfung:  </a:t>
+              <a:t>Zeitfenster:  </a:t>
             </a:r>
             <a:pPr indent="0" marL="0">
               <a:buNone/>
@@ -2611,7 +2609,7 @@
                 <a:ea typeface="Arial" pitchFamily="34" charset="-122"/>
                 <a:cs typeface="Arial" pitchFamily="34" charset="-120"/>
               </a:rPr>
-              <a:t>cuckoo_onTime ≤ hour ≤ cuckoo_offTime  (normal). Bei Mitternacht-Überlauf (z.B. 22–06): hour ≥ onTime ODER hour ≤ offTime.</a:t>
+              <a:t>cuckoo_onTime ≤ hour ≤ cuckoo_offTime  (normal). Mitternacht-Überlauf: hour ≥ onTime ODER hour ≤ offTime.</a:t>
             </a:r>
             <a:pPr indent="0" marL="0">
               <a:buNone/>
@@ -2697,7 +2695,7 @@
                 <a:ea typeface="Arial" pitchFamily="34" charset="-122"/>
                 <a:cs typeface="Arial" pitchFamily="34" charset="-120"/>
               </a:rPr>
-              <a:t>lastCuckooMin wird auf t_min gesetzt und erst nach CUCKOO_RUNNING→IDLE auf 0xFF zurückgesetzt.</a:t>
+              <a:t>lastCuckooMin = t_min nach Auslösung; = 0xFF nach CUCKOO_RUNNING→IDLE (Sperre aufheben).</a:t>
             </a:r>
             <a:endParaRPr lang="en-US" sz="900" dirty="0"/>
           </a:p>
@@ -2793,7 +2791,7 @@
                 <a:ea typeface="Arial" pitchFamily="34" charset="-122"/>
                 <a:cs typeface="Arial" pitchFamily="34" charset="-120"/>
               </a:rPr>
-              <a:t>Touch-State-Machine  ·  touchTask (Core 0, Pri 2)  ·  Takt: TOUCH_POLL_MS</a:t>
+              <a:t>Touch-State-Machine  ·  touchTask (Core 0, Pri 2)  ·  Takt: TOUCH_POLL_MS (50 ms)</a:t>
             </a:r>
             <a:endParaRPr lang="en-US" sz="1800" dirty="0"/>
           </a:p>
@@ -3652,7 +3650,7 @@
                 <a:ea typeface="Arial" pitchFamily="34" charset="-122"/>
                 <a:cs typeface="Arial" pitchFamily="34" charset="-120"/>
               </a:rPr>
-              <a:t>padWert &lt; (baseline − TOUCH_DROP)  → Touch erkannt. Fallback wenn baseline &lt; TOUCH_DROP: 80% der Baseline.</a:t>
+              <a:t>padWert &lt; (baseline − TOUCH_DROP=150)  → Touch erkannt. Fallback wenn baseline &lt; TOUCH_DROP: 80% der Baseline.</a:t>
             </a:r>
             <a:pPr indent="0" marL="0">
               <a:buNone/>
@@ -3695,7 +3693,7 @@
                 <a:ea typeface="Arial" pitchFamily="34" charset="-122"/>
                 <a:cs typeface="Arial" pitchFamily="34" charset="-120"/>
               </a:rPr>
-              <a:t>Sobald ein Pad aktiv ist (TS_PRESSED/TS_REPEAT) werden alle anderen Pads ignoriert.</a:t>
+              <a:t>Sobald ein Pad aktiv (TS_PRESSED/TS_REPEAT), alle anderen ignoriert. Baseline-Rekalibrierung alle 10 min im TS_IDLE.</a:t>
             </a:r>
             <a:pPr indent="0" marL="0">
               <a:buNone/>
@@ -3724,7 +3722,7 @@
                 <a:ea typeface="Arial" pitchFamily="34" charset="-122"/>
                 <a:cs typeface="Arial" pitchFamily="34" charset="-120"/>
               </a:rPr>
-              <a:t>ISR Debouncing (Stufe 1):  </a:t>
+              <a:t>ISR Debouncing:  </a:t>
             </a:r>
             <a:pPr indent="0" marL="0">
               <a:buNone/>
@@ -3738,7 +3736,7 @@
                 <a:ea typeface="Arial" pitchFamily="34" charset="-122"/>
                 <a:cs typeface="Arial" pitchFamily="34" charset="-120"/>
               </a:rPr>
-              <a:t>Flanken &lt; BTN_DEBOUNCE_MS (30 ms) werden in der ISR verworfen → saubere Queue. Stufe 2 (inputTask): BTN_LOCKOUT_MS (1000 ms) Aktionssperre.</a:t>
+              <a:t>S1–S3: Flanken &lt; BTN_DEBOUNCE_MS (30 ms) in ISR verworfen → saubere Queue. Aktionssperre inputTask: BTN_LOCKOUT_MS (1000 ms).</a:t>
             </a:r>
             <a:endParaRPr lang="en-US" sz="900" dirty="0"/>
           </a:p>
@@ -5228,7 +5226,7 @@
                 <a:ea typeface="Arial" pitchFamily="34" charset="-122"/>
                 <a:cs typeface="Arial" pitchFamily="34" charset="-120"/>
               </a:rPr>
-              <a:t>Info-Seite</a:t>
+              <a:t>Info-Seite (S3)</a:t>
             </a:r>
             <a:endParaRPr lang="en-US" sz="900" dirty="0"/>
           </a:p>
@@ -5532,8 +5530,8 @@
         </p:nvSpPr>
         <p:spPr>
           <a:xfrm>
-            <a:off x="2926080" y="3977640"/>
-            <a:ext cx="2286000" cy="502920"/>
+            <a:off x="2971800" y="3977640"/>
+            <a:ext cx="2194560" cy="502920"/>
           </a:xfrm>
           <a:prstGeom prst="rect">
             <a:avLst/>
@@ -5551,7 +5549,7 @@
             <a:r>
               <a:rPr lang="en-US" sz="750" dirty="0">
                 <a:solidFill>
-                  <a:srgbClr val="5D4037"/>
+                  <a:srgbClr val="F9A825"/>
                 </a:solidFill>
                 <a:latin typeface="Arial" pitchFamily="34" charset="0"/>
                 <a:ea typeface="Arial" pitchFamily="34" charset="-122"/>
@@ -5568,7 +5566,7 @@
             <a:r>
               <a:rPr lang="en-US" sz="750" dirty="0">
                 <a:solidFill>
-                  <a:srgbClr val="5D4037"/>
+                  <a:srgbClr val="F9A825"/>
                 </a:solidFill>
                 <a:latin typeface="Arial" pitchFamily="34" charset="0"/>
                 <a:ea typeface="Arial" pitchFamily="34" charset="-122"/>
@@ -5702,8 +5700,8 @@
         </p:nvSpPr>
         <p:spPr>
           <a:xfrm>
-            <a:off x="2926080" y="4617720"/>
-            <a:ext cx="2286000" cy="502920"/>
+            <a:off x="2971800" y="4617720"/>
+            <a:ext cx="2194560" cy="502920"/>
           </a:xfrm>
           <a:prstGeom prst="rect">
             <a:avLst/>
@@ -5939,7 +5937,7 @@
               <a:buNone/>
             </a:pPr>
             <a:r>
-              <a:rPr lang="en-US" sz="850" dirty="0">
+              <a:rPr lang="en-US" sz="800" dirty="0">
                 <a:solidFill>
                   <a:srgbClr val="1B5E20"/>
                 </a:solidFill>
@@ -5947,9 +5945,9 @@
                 <a:ea typeface="Arial" pitchFamily="34" charset="-122"/>
                 <a:cs typeface="Arial" pitchFamily="34" charset="-120"/>
               </a:rPr>
-              <a:t>Auto-Rückkehr nach AUTO_RETURN_MS (20 s) ohne Touch → UI_CLOCK  (ausgenommen: UI_INFO)</a:t>
-            </a:r>
-            <a:endParaRPr lang="en-US" sz="850" dirty="0"/>
+              <a:t>Auto-Rückkehr nach AUTO_RETURN_MS (20 s) ohne Touch → UI_CLOCK  (ab 9v6: auch von UI_INFO · S3 aktualisiert lastTouchMs seit 9v7)</a:t>
+            </a:r>
+            <a:endParaRPr lang="en-US" sz="800" dirty="0"/>
           </a:p>
         </p:txBody>
       </p:sp>

</xml_diff>

<commit_message>
Doku: StateMachines.pptx auf 11v00 (playerStatus == 0)
Slide 0 (Alarm-FSM): Übergang RUNNING→IDLE aktualisiert –
'playerStatus < 1' → 'playerStatus == 0' (9v4-Fix).
Formatierung/Runs erhalten.

Co-Authored-By: Claude Opus 4.7 <noreply@anthropic.com>
</commit_message>
<xml_diff>
--- a/Dokumentation/Diagramme/bTn_Wecker_StateMachines.pptx
+++ b/Dokumentation/Diagramme/bTn_Wecker_StateMachines.pptx
@@ -1473,7 +1473,7 @@
                 <a:ea typeface="Arial" pitchFamily="34" charset="-122"/>
                 <a:cs typeface="Arial" pitchFamily="34" charset="-120"/>
               </a:rPr>
-              <a:t>playerStatus &lt; 1  (MP3 </a:t>
+              <a:t>playerStatus == 0  (MP3 </a:t>
             </a:r>
             <a:r>
               <a:rPr lang="en-US" sz="1000" i="1" dirty="0" err="1">
@@ -1711,7 +1711,7 @@
                 <a:latin typeface="Arial" panose="020B0604020202020204" pitchFamily="34" charset="0"/>
                 <a:ea typeface="Arial" panose="020B0604020202020204" pitchFamily="34" charset="0"/>
               </a:rPr>
-              <a:t> &lt; 1 (MP3 beendet)</a:t>
+              <a:t> == 0 (MP3 beendet)</a:t>
             </a:r>
             <a:endParaRPr lang="de-DE" sz="1050" dirty="0">
               <a:effectLst/>

</xml_diff>

<commit_message>
Doku: StateMachines.pptx – Display-Timeout auf Slide 3 ergänzt
UI-Slide: Annotation um DISPLAY_TIMEOUT_MS-Verhalten erweitert
(OLED-Abschaltung nach 5 min, Touch-Wake verwirft Event).
Formatierung des Original-Absatzes übernommen.

Co-Authored-By: Claude Opus 4.7 <noreply@anthropic.com>
</commit_message>
<xml_diff>
--- a/Dokumentation/Diagramme/bTn_Wecker_StateMachines.pptx
+++ b/Dokumentation/Diagramme/bTn_Wecker_StateMachines.pptx
@@ -5505,6 +5505,23 @@
                 <a:cs typeface="Arial" pitchFamily="34" charset="-120"/>
               </a:rPr>
               <a:t>Auto-Rückkehr nach AUTO_RETURN_MS (20 s) ohne Touch → UI_CLOCK</a:t>
+            </a:r>
+            <a:endParaRPr lang="en-US" sz="1000" dirty="0"/>
+          </a:p>
+          <a:p>
+            <a:pPr marL="0" indent="0" algn="ctr">
+              <a:buNone/>
+            </a:pPr>
+            <a:r>
+              <a:rPr lang="en-US" sz="1000" dirty="0">
+                <a:solidFill>
+                  <a:srgbClr val="1B5E20"/>
+                </a:solidFill>
+                <a:latin typeface="Arial" pitchFamily="34" charset="0"/>
+                <a:ea typeface="Arial" pitchFamily="34" charset="-122"/>
+                <a:cs typeface="Arial" pitchFamily="34" charset="-120"/>
+              </a:rPr>
+              <a:t>Display-Timeout: OLED schaltet nach DISPLAY_TIMEOUT_MS (5 min) ohne Touch ab; jeder Touch weckt das Display, das auslösende Event wird verworfen</a:t>
             </a:r>
             <a:endParaRPr lang="en-US" sz="1000" dirty="0"/>
           </a:p>

</xml_diff>

<commit_message>
Doku: Formatierungsanpassungen in Bedienungsanleitung.docx und StateMachines.pptx
Reine Formatierung, keine inhaltlichen Änderungen.

Co-Authored-By: Claude Opus 4.7 <noreply@anthropic.com>
</commit_message>
<xml_diff>
--- a/Dokumentation/Diagramme/bTn_Wecker_StateMachines.pptx
+++ b/Dokumentation/Diagramme/bTn_Wecker_StateMachines.pptx
@@ -5455,7 +5455,7 @@
         <p:spPr>
           <a:xfrm>
             <a:off x="3060000" y="2304000"/>
-            <a:ext cx="8172000" cy="432000"/>
+            <a:ext cx="8172000" cy="612000"/>
           </a:xfrm>
           <a:prstGeom prst="rect">
             <a:avLst/>
@@ -5480,7 +5480,7 @@
         <p:spPr>
           <a:xfrm>
             <a:off x="3060000" y="2304000"/>
-            <a:ext cx="8172000" cy="432000"/>
+            <a:ext cx="8172000" cy="612000"/>
           </a:xfrm>
           <a:prstGeom prst="rect">
             <a:avLst/>
@@ -5521,7 +5521,34 @@
                 <a:ea typeface="Arial" pitchFamily="34" charset="-122"/>
                 <a:cs typeface="Arial" pitchFamily="34" charset="-120"/>
               </a:rPr>
-              <a:t>Display-Timeout: OLED schaltet nach DISPLAY_TIMEOUT_MS (5 min) ohne Touch ab; jeder Touch weckt das Display, das auslösende Event wird verworfen</a:t>
+              <a:t>Display-Timeout: OLED schaltet nach DISPLAY_TIMEOUT_MS (5 min) ohne Touch ab;</a:t>
+            </a:r>
+          </a:p>
+          <a:p>
+            <a:pPr marL="0" indent="0" algn="ctr">
+              <a:buNone/>
+            </a:pPr>
+            <a:r>
+              <a:rPr lang="en-US" sz="1000" dirty="0" err="1">
+                <a:solidFill>
+                  <a:srgbClr val="1B5E20"/>
+                </a:solidFill>
+                <a:latin typeface="Arial" pitchFamily="34" charset="0"/>
+                <a:ea typeface="Arial" pitchFamily="34" charset="-122"/>
+                <a:cs typeface="Arial" pitchFamily="34" charset="-120"/>
+              </a:rPr>
+              <a:t>jeder</a:t>
+            </a:r>
+            <a:r>
+              <a:rPr lang="en-US" sz="1000" dirty="0">
+                <a:solidFill>
+                  <a:srgbClr val="1B5E20"/>
+                </a:solidFill>
+                <a:latin typeface="Arial" pitchFamily="34" charset="0"/>
+                <a:ea typeface="Arial" pitchFamily="34" charset="-122"/>
+                <a:cs typeface="Arial" pitchFamily="34" charset="-120"/>
+              </a:rPr>
+              <a:t> Touch weckt das Display, das auslösende Event wird verworfen</a:t>
             </a:r>
             <a:endParaRPr lang="en-US" sz="1000" dirty="0"/>
           </a:p>
@@ -7780,7 +7807,7 @@
         </p:nvSpPr>
         <p:spPr>
           <a:xfrm flipH="1" flipV="1">
-            <a:off x="1955954" y="2528990"/>
+            <a:off x="1955954" y="2618991"/>
             <a:ext cx="1080000" cy="0"/>
           </a:xfrm>
           <a:prstGeom prst="line">

</xml_diff>